<commit_message>
6/10 EOD Update. Halfway done AE meetings.
</commit_message>
<xml_diff>
--- a/Flour_Frontier_Final_Presentation.pptx
+++ b/Flour_Frontier_Final_Presentation.pptx
@@ -131,20 +131,12 @@
 </p:presentation>
 </file>
 
-<file path=ppt/revisionInfo.xml><?xml version="1.0" encoding="utf-8"?>
-<p1510:revInfo xmlns:a="http://schemas.openxmlformats.org/drawingml/2006/main" xmlns:r="http://schemas.openxmlformats.org/officeDocument/2006/relationships" xmlns:p1510="http://schemas.microsoft.com/office/powerpoint/2015/10/main">
-  <p1510:revLst>
-    <p1510:client id="{09A975E3-D1F3-465C-9BCF-FB7E18AF5D93}" v="1" dt="2026-05-29T13:33:01.739"/>
-  </p1510:revLst>
-</p1510:revInfo>
-</file>
-
 <file path=ppt/changesInfos/changesInfo1.xml><?xml version="1.0" encoding="utf-8"?>
 <pc:chgInfo xmlns:a="http://schemas.openxmlformats.org/drawingml/2006/main" xmlns:r="http://schemas.openxmlformats.org/officeDocument/2006/relationships" xmlns:ac="http://schemas.microsoft.com/office/drawing/2013/main/command" xmlns:pc="http://schemas.microsoft.com/office/powerpoint/2013/main/command">
   <pc:docChgLst>
     <pc:chgData name="Jake Gilstein" userId="62cb0a79-6670-4fbc-800d-9777482770ad" providerId="ADAL" clId="{E8E93B12-7B5D-4D61-AB68-55954BC0EA68}"/>
     <pc:docChg chg="modSld">
-      <pc:chgData name="Jake Gilstein" userId="62cb0a79-6670-4fbc-800d-9777482770ad" providerId="ADAL" clId="{E8E93B12-7B5D-4D61-AB68-55954BC0EA68}" dt="2026-05-29T17:20:27.593" v="1" actId="6549"/>
+      <pc:chgData name="Jake Gilstein" userId="62cb0a79-6670-4fbc-800d-9777482770ad" providerId="ADAL" clId="{E8E93B12-7B5D-4D61-AB68-55954BC0EA68}" dt="2026-06-08T16:46:54.902" v="14" actId="20577"/>
       <pc:docMkLst>
         <pc:docMk/>
       </pc:docMkLst>
@@ -160,6 +152,29 @@
             <pc:docMk/>
             <pc:sldMk cId="0" sldId="260"/>
             <ac:spMk id="18" creationId="{00000000-0000-0000-0000-000000000000}"/>
+          </ac:spMkLst>
+        </pc:spChg>
+      </pc:sldChg>
+      <pc:sldChg chg="modSp mod">
+        <pc:chgData name="Jake Gilstein" userId="62cb0a79-6670-4fbc-800d-9777482770ad" providerId="ADAL" clId="{E8E93B12-7B5D-4D61-AB68-55954BC0EA68}" dt="2026-06-08T16:46:54.902" v="14" actId="20577"/>
+        <pc:sldMkLst>
+          <pc:docMk/>
+          <pc:sldMk cId="0" sldId="265"/>
+        </pc:sldMkLst>
+        <pc:spChg chg="mod">
+          <ac:chgData name="Jake Gilstein" userId="62cb0a79-6670-4fbc-800d-9777482770ad" providerId="ADAL" clId="{E8E93B12-7B5D-4D61-AB68-55954BC0EA68}" dt="2026-06-08T16:46:54.902" v="14" actId="20577"/>
+          <ac:spMkLst>
+            <pc:docMk/>
+            <pc:sldMk cId="0" sldId="265"/>
+            <ac:spMk id="8" creationId="{00000000-0000-0000-0000-000000000000}"/>
+          </ac:spMkLst>
+        </pc:spChg>
+        <pc:spChg chg="mod">
+          <ac:chgData name="Jake Gilstein" userId="62cb0a79-6670-4fbc-800d-9777482770ad" providerId="ADAL" clId="{E8E93B12-7B5D-4D61-AB68-55954BC0EA68}" dt="2026-06-08T16:46:38.807" v="2" actId="20577"/>
+          <ac:spMkLst>
+            <pc:docMk/>
+            <pc:sldMk cId="0" sldId="265"/>
+            <ac:spMk id="9" creationId="{00000000-0000-0000-0000-000000000000}"/>
           </ac:spMkLst>
         </pc:spChg>
       </pc:sldChg>
@@ -1040,7 +1055,7 @@
           <a:p>
             <a:fld id="{5BCAD085-E8A6-8845-BD4E-CB4CCA059FC4}" type="datetimeFigureOut">
               <a:rPr lang="en-US" smtClean="0"/>
-              <a:t>5/29/2026</a:t>
+              <a:t>6/8/2026</a:t>
             </a:fld>
             <a:endParaRPr lang="en-US"/>
           </a:p>
@@ -1208,7 +1223,7 @@
           <a:p>
             <a:fld id="{5BCAD085-E8A6-8845-BD4E-CB4CCA059FC4}" type="datetimeFigureOut">
               <a:rPr lang="en-US" smtClean="0"/>
-              <a:t>5/29/2026</a:t>
+              <a:t>6/8/2026</a:t>
             </a:fld>
             <a:endParaRPr lang="en-US"/>
           </a:p>
@@ -1386,7 +1401,7 @@
           <a:p>
             <a:fld id="{5BCAD085-E8A6-8845-BD4E-CB4CCA059FC4}" type="datetimeFigureOut">
               <a:rPr lang="en-US" smtClean="0"/>
-              <a:t>5/29/2026</a:t>
+              <a:t>6/8/2026</a:t>
             </a:fld>
             <a:endParaRPr lang="en-US"/>
           </a:p>
@@ -1659,7 +1674,7 @@
           </a:prstGeom>
           <a:extLst>
             <a:ext uri="{C572A759-6A51-4108-AA02-DFA0A04FC94B}">
-              <ma14:wrappingTextBoxFlag xmlns:ma14="http://schemas.microsoft.com/office/mac/drawingml/2011/main" xmlns="" val="0"/>
+              <ma14:wrappingTextBoxFlag xmlns="" xmlns:ma14="http://schemas.microsoft.com/office/mac/drawingml/2011/main" val="0"/>
             </a:ext>
           </a:extLst>
         </p:spPr>
@@ -1807,7 +1822,7 @@
           <a:p>
             <a:fld id="{5BCAD085-E8A6-8845-BD4E-CB4CCA059FC4}" type="datetimeFigureOut">
               <a:rPr lang="en-US" smtClean="0"/>
-              <a:t>5/29/2026</a:t>
+              <a:t>6/8/2026</a:t>
             </a:fld>
             <a:endParaRPr lang="en-US"/>
           </a:p>
@@ -2052,7 +2067,7 @@
           <a:p>
             <a:fld id="{5BCAD085-E8A6-8845-BD4E-CB4CCA059FC4}" type="datetimeFigureOut">
               <a:rPr lang="en-US" smtClean="0"/>
-              <a:t>5/29/2026</a:t>
+              <a:t>6/8/2026</a:t>
             </a:fld>
             <a:endParaRPr lang="en-US"/>
           </a:p>
@@ -2337,7 +2352,7 @@
           <a:p>
             <a:fld id="{5BCAD085-E8A6-8845-BD4E-CB4CCA059FC4}" type="datetimeFigureOut">
               <a:rPr lang="en-US" smtClean="0"/>
-              <a:t>5/29/2026</a:t>
+              <a:t>6/8/2026</a:t>
             </a:fld>
             <a:endParaRPr lang="en-US"/>
           </a:p>
@@ -2756,7 +2771,7 @@
           <a:p>
             <a:fld id="{5BCAD085-E8A6-8845-BD4E-CB4CCA059FC4}" type="datetimeFigureOut">
               <a:rPr lang="en-US" smtClean="0"/>
-              <a:t>5/29/2026</a:t>
+              <a:t>6/8/2026</a:t>
             </a:fld>
             <a:endParaRPr lang="en-US"/>
           </a:p>
@@ -2873,7 +2888,7 @@
           <a:p>
             <a:fld id="{5BCAD085-E8A6-8845-BD4E-CB4CCA059FC4}" type="datetimeFigureOut">
               <a:rPr lang="en-US" smtClean="0"/>
-              <a:t>5/29/2026</a:t>
+              <a:t>6/8/2026</a:t>
             </a:fld>
             <a:endParaRPr lang="en-US"/>
           </a:p>
@@ -2968,7 +2983,7 @@
           <a:p>
             <a:fld id="{5BCAD085-E8A6-8845-BD4E-CB4CCA059FC4}" type="datetimeFigureOut">
               <a:rPr lang="en-US" smtClean="0"/>
-              <a:t>5/29/2026</a:t>
+              <a:t>6/8/2026</a:t>
             </a:fld>
             <a:endParaRPr lang="en-US"/>
           </a:p>
@@ -3243,7 +3258,7 @@
           <a:p>
             <a:fld id="{5BCAD085-E8A6-8845-BD4E-CB4CCA059FC4}" type="datetimeFigureOut">
               <a:rPr lang="en-US" smtClean="0"/>
-              <a:t>5/29/2026</a:t>
+              <a:t>6/8/2026</a:t>
             </a:fld>
             <a:endParaRPr lang="en-US"/>
           </a:p>
@@ -3495,7 +3510,7 @@
           <a:p>
             <a:fld id="{5BCAD085-E8A6-8845-BD4E-CB4CCA059FC4}" type="datetimeFigureOut">
               <a:rPr lang="en-US" smtClean="0"/>
-              <a:t>5/29/2026</a:t>
+              <a:t>6/8/2026</a:t>
             </a:fld>
             <a:endParaRPr lang="en-US"/>
           </a:p>
@@ -3706,7 +3721,7 @@
           <a:p>
             <a:fld id="{5BCAD085-E8A6-8845-BD4E-CB4CCA059FC4}" type="datetimeFigureOut">
               <a:rPr lang="en-US" smtClean="0"/>
-              <a:t>5/29/2026</a:t>
+              <a:t>6/8/2026</a:t>
             </a:fld>
             <a:endParaRPr lang="en-US"/>
           </a:p>
@@ -4106,7 +4121,7 @@
           </a:prstGeom>
           <a:extLst>
             <a:ext uri="{C572A759-6A51-4108-AA02-DFA0A04FC94B}">
-              <ma14:wrappingTextBoxFlag xmlns:ma14="http://schemas.microsoft.com/office/mac/drawingml/2011/main" xmlns="" val="0"/>
+              <ma14:wrappingTextBoxFlag xmlns="" xmlns:ma14="http://schemas.microsoft.com/office/mac/drawingml/2011/main" val="0"/>
             </a:ext>
           </a:extLst>
         </p:spPr>
@@ -4797,52 +4812,7 @@
                 <a:ea typeface="Carlito" pitchFamily="34" charset="-122"/>
                 <a:cs typeface="Times New Roman" panose="02020603050405020304" pitchFamily="18" charset="0"/>
               </a:rPr>
-              <a:t>University of South Florida ·  Business Management </a:t>
-            </a:r>
-            <a:r>
-              <a:rPr lang="en-US" sz="1400" dirty="0">
-                <a:solidFill>
-                  <a:schemeClr val="bg1"/>
-                </a:solidFill>
-                <a:latin typeface="Times New Roman" panose="02020603050405020304" pitchFamily="18" charset="0"/>
-                <a:ea typeface="Carlito" pitchFamily="34" charset="-122"/>
-                <a:cs typeface="Times New Roman" panose="02020603050405020304" pitchFamily="18" charset="0"/>
-              </a:rPr>
-              <a:t>M</a:t>
-            </a:r>
-            <a:r>
-              <a:rPr kumimoji="0" lang="en-US" sz="1400" b="0" i="0" u="none" strike="noStrike" kern="1200" cap="none" spc="0" normalizeH="0" baseline="0" noProof="0" dirty="0" err="1">
-                <a:ln>
-                  <a:noFill/>
-                </a:ln>
-                <a:solidFill>
-                  <a:schemeClr val="bg1"/>
-                </a:solidFill>
-                <a:effectLst/>
-                <a:uLnTx/>
-                <a:uFillTx/>
-                <a:latin typeface="Times New Roman" panose="02020603050405020304" pitchFamily="18" charset="0"/>
-                <a:ea typeface="Carlito" pitchFamily="34" charset="-122"/>
-                <a:cs typeface="Times New Roman" panose="02020603050405020304" pitchFamily="18" charset="0"/>
-              </a:rPr>
-              <a:t>ajor</a:t>
-            </a:r>
-            <a:r>
-              <a:rPr kumimoji="0" lang="en-US" sz="1400" b="0" i="0" u="none" strike="noStrike" kern="1200" cap="none" spc="0" normalizeH="0" baseline="0" noProof="0" dirty="0">
-                <a:ln>
-                  <a:noFill/>
-                </a:ln>
-                <a:solidFill>
-                  <a:schemeClr val="bg1"/>
-                </a:solidFill>
-                <a:effectLst/>
-                <a:uLnTx/>
-                <a:uFillTx/>
-                <a:latin typeface="Times New Roman" panose="02020603050405020304" pitchFamily="18" charset="0"/>
-                <a:ea typeface="Carlito" pitchFamily="34" charset="-122"/>
-                <a:cs typeface="Times New Roman" panose="02020603050405020304" pitchFamily="18" charset="0"/>
-              </a:rPr>
-              <a:t> &amp; Marketing Minor </a:t>
+              <a:t>University of South Florida ·  Business Management Major &amp; Marketing Minor </a:t>
             </a:r>
             <a:r>
               <a:rPr lang="en-US" sz="1400" dirty="0">
@@ -4927,7 +4897,7 @@
                 <a:ea typeface="Carlito" pitchFamily="34" charset="-122"/>
                 <a:cs typeface="Times New Roman" panose="02020603050405020304" pitchFamily="18" charset="0"/>
               </a:rPr>
-              <a:t>10 weeks · Flour Frontiers Project · Manager: James Mueting · Mentor: Catherine Colon</a:t>
+              <a:t>10 weeks · Flour Frontier Project · Manager: James Mueting · Mentor: Catherine Colon</a:t>
             </a:r>
             <a:r>
               <a:rPr lang="en-US" sz="1200" dirty="0">

</xml_diff>